<commit_message>
cambion menores y/o pendientes de actualizar
</commit_message>
<xml_diff>
--- a/Fase 3/Evidencias Grupales/Presentación Proyecto.pptx
+++ b/Fase 3/Evidencias Grupales/Presentación Proyecto.pptx
@@ -5,7 +5,7 @@
     <p:sldMasterId id="2147483726" r:id="rId1"/>
   </p:sldMasterIdLst>
   <p:notesMasterIdLst>
-    <p:notesMasterId r:id="rId17"/>
+    <p:notesMasterId r:id="rId18"/>
   </p:notesMasterIdLst>
   <p:sldIdLst>
     <p:sldId id="256" r:id="rId2"/>
@@ -19,35 +19,36 @@
     <p:sldId id="264" r:id="rId10"/>
     <p:sldId id="278" r:id="rId11"/>
     <p:sldId id="270" r:id="rId12"/>
-    <p:sldId id="280" r:id="rId13"/>
-    <p:sldId id="282" r:id="rId14"/>
-    <p:sldId id="269" r:id="rId15"/>
-    <p:sldId id="274" r:id="rId16"/>
+    <p:sldId id="283" r:id="rId13"/>
+    <p:sldId id="280" r:id="rId14"/>
+    <p:sldId id="282" r:id="rId15"/>
+    <p:sldId id="269" r:id="rId16"/>
+    <p:sldId id="274" r:id="rId17"/>
   </p:sldIdLst>
   <p:sldSz cx="14630400" cy="8229600"/>
   <p:notesSz cx="8229600" cy="14630400"/>
   <p:embeddedFontLst>
     <p:embeddedFont>
       <p:font typeface="Aptos Narrow" panose="020B0004020202020204" pitchFamily="34" charset="0"/>
-      <p:regular r:id="rId18"/>
-      <p:bold r:id="rId19"/>
-      <p:italic r:id="rId20"/>
-      <p:boldItalic r:id="rId21"/>
+      <p:regular r:id="rId19"/>
+      <p:bold r:id="rId20"/>
+      <p:italic r:id="rId21"/>
+      <p:boldItalic r:id="rId22"/>
     </p:embeddedFont>
     <p:embeddedFont>
       <p:font typeface="Gill Sans MT" panose="020B0502020104020203" pitchFamily="34" charset="0"/>
-      <p:regular r:id="rId22"/>
-      <p:bold r:id="rId23"/>
-      <p:italic r:id="rId24"/>
-      <p:boldItalic r:id="rId25"/>
+      <p:regular r:id="rId23"/>
+      <p:bold r:id="rId24"/>
+      <p:italic r:id="rId25"/>
+      <p:boldItalic r:id="rId26"/>
     </p:embeddedFont>
     <p:embeddedFont>
       <p:font typeface="Source Sans 3" panose="020B0604020202020204" charset="0"/>
-      <p:regular r:id="rId26"/>
+      <p:regular r:id="rId27"/>
     </p:embeddedFont>
     <p:embeddedFont>
       <p:font typeface="Source Serif 4 Semi Bold" panose="020B0604020202020204" charset="0"/>
-      <p:regular r:id="rId27"/>
+      <p:regular r:id="rId28"/>
     </p:embeddedFont>
   </p:embeddedFontLst>
   <p:defaultTextStyle>
@@ -695,7 +696,7 @@
           <a:p>
             <a:fld id="{F7021451-1387-4CA6-816F-3879F97B5CBC}" type="slidenum">
               <a:rPr lang="en-US"/>
-              <a:t>12</a:t>
+              <a:t>13</a:t>
             </a:fld>
             <a:endParaRPr lang="en-US"/>
           </a:p>
@@ -810,7 +811,7 @@
           <a:p>
             <a:fld id="{F7021451-1387-4CA6-816F-3879F97B5CBC}" type="slidenum">
               <a:rPr lang="en-US"/>
-              <a:t>13</a:t>
+              <a:t>14</a:t>
             </a:fld>
             <a:endParaRPr lang="en-US"/>
           </a:p>
@@ -925,7 +926,7 @@
           <a:p>
             <a:fld id="{F7021451-1387-4CA6-816F-3879F97B5CBC}" type="slidenum">
               <a:rPr lang="en-US"/>
-              <a:t>14</a:t>
+              <a:t>15</a:t>
             </a:fld>
             <a:endParaRPr lang="en-US"/>
           </a:p>
@@ -1040,7 +1041,7 @@
           <a:p>
             <a:fld id="{F7021451-1387-4CA6-816F-3879F97B5CBC}" type="slidenum">
               <a:rPr lang="en-US"/>
-              <a:t>15</a:t>
+              <a:t>16</a:t>
             </a:fld>
             <a:endParaRPr lang="en-US"/>
           </a:p>
@@ -1926,7 +1927,7 @@
           <a:p>
             <a:fld id="{48A87A34-81AB-432B-8DAE-1953F412C126}" type="datetimeFigureOut">
               <a:rPr lang="en-US" smtClean="0"/>
-              <a:t>11/10/2025</a:t>
+              <a:t>11/25/2025</a:t>
             </a:fld>
             <a:endParaRPr lang="en-US" dirty="0"/>
           </a:p>
@@ -2138,7 +2139,7 @@
           <a:p>
             <a:fld id="{48A87A34-81AB-432B-8DAE-1953F412C126}" type="datetimeFigureOut">
               <a:rPr lang="en-US" smtClean="0"/>
-              <a:t>11/10/2025</a:t>
+              <a:t>11/25/2025</a:t>
             </a:fld>
             <a:endParaRPr lang="en-US" dirty="0"/>
           </a:p>
@@ -2354,7 +2355,7 @@
           <a:p>
             <a:fld id="{48A87A34-81AB-432B-8DAE-1953F412C126}" type="datetimeFigureOut">
               <a:rPr lang="en-US" smtClean="0"/>
-              <a:t>11/10/2025</a:t>
+              <a:t>11/25/2025</a:t>
             </a:fld>
             <a:endParaRPr lang="en-US" dirty="0"/>
           </a:p>
@@ -2796,7 +2797,7 @@
           <a:p>
             <a:fld id="{48A87A34-81AB-432B-8DAE-1953F412C126}" type="datetimeFigureOut">
               <a:rPr lang="en-US" smtClean="0"/>
-              <a:t>11/10/2025</a:t>
+              <a:t>11/25/2025</a:t>
             </a:fld>
             <a:endParaRPr lang="en-US" dirty="0"/>
           </a:p>
@@ -3106,7 +3107,7 @@
           <a:p>
             <a:fld id="{48A87A34-81AB-432B-8DAE-1953F412C126}" type="datetimeFigureOut">
               <a:rPr lang="en-US" smtClean="0"/>
-              <a:t>11/10/2025</a:t>
+              <a:t>11/25/2025</a:t>
             </a:fld>
             <a:endParaRPr lang="en-US" dirty="0"/>
           </a:p>
@@ -3375,7 +3376,7 @@
           <a:p>
             <a:fld id="{48A87A34-81AB-432B-8DAE-1953F412C126}" type="datetimeFigureOut">
               <a:rPr lang="en-US" smtClean="0"/>
-              <a:t>11/10/2025</a:t>
+              <a:t>11/25/2025</a:t>
             </a:fld>
             <a:endParaRPr lang="en-US" dirty="0"/>
           </a:p>
@@ -3792,7 +3793,7 @@
           <a:p>
             <a:fld id="{48A87A34-81AB-432B-8DAE-1953F412C126}" type="datetimeFigureOut">
               <a:rPr lang="en-US" smtClean="0"/>
-              <a:t>11/10/2025</a:t>
+              <a:t>11/25/2025</a:t>
             </a:fld>
             <a:endParaRPr lang="en-US" dirty="0"/>
           </a:p>
@@ -3942,7 +3943,7 @@
           <a:p>
             <a:fld id="{48A87A34-81AB-432B-8DAE-1953F412C126}" type="datetimeFigureOut">
               <a:rPr lang="en-US" smtClean="0"/>
-              <a:t>11/10/2025</a:t>
+              <a:t>11/25/2025</a:t>
             </a:fld>
             <a:endParaRPr lang="en-US" dirty="0"/>
           </a:p>
@@ -4069,7 +4070,7 @@
           <a:p>
             <a:fld id="{48A87A34-81AB-432B-8DAE-1953F412C126}" type="datetimeFigureOut">
               <a:rPr lang="en-US" smtClean="0"/>
-              <a:t>11/10/2025</a:t>
+              <a:t>11/25/2025</a:t>
             </a:fld>
             <a:endParaRPr lang="en-US" dirty="0"/>
           </a:p>
@@ -4321,7 +4322,7 @@
           <a:p>
             <a:fld id="{48A87A34-81AB-432B-8DAE-1953F412C126}" type="datetimeFigureOut">
               <a:rPr lang="en-US" smtClean="0"/>
-              <a:t>11/10/2025</a:t>
+              <a:t>11/25/2025</a:t>
             </a:fld>
             <a:endParaRPr lang="en-US" dirty="0"/>
           </a:p>
@@ -4782,7 +4783,7 @@
             <a:fld id="{48A87A34-81AB-432B-8DAE-1953F412C126}" type="datetimeFigureOut">
               <a:rPr lang="en-US" smtClean="0"/>
               <a:pPr/>
-              <a:t>11/10/2025</a:t>
+              <a:t>11/25/2025</a:t>
             </a:fld>
             <a:endParaRPr lang="en-US" dirty="0"/>
           </a:p>
@@ -5118,7 +5119,7 @@
             <a:fld id="{48A87A34-81AB-432B-8DAE-1953F412C126}" type="datetimeFigureOut">
               <a:rPr lang="en-US" smtClean="0"/>
               <a:pPr/>
-              <a:t>11/10/2025</a:t>
+              <a:t>11/25/2025</a:t>
             </a:fld>
             <a:endParaRPr lang="en-US" dirty="0"/>
           </a:p>
@@ -6237,6 +6238,342 @@
   <p:cSld>
     <p:spTree>
       <p:nvGrpSpPr>
+        <p:cNvPr id="1" name=""/>
+        <p:cNvGrpSpPr/>
+        <p:nvPr/>
+      </p:nvGrpSpPr>
+      <p:grpSpPr>
+        <a:xfrm>
+          <a:off x="0" y="0"/>
+          <a:ext cx="0" cy="0"/>
+          <a:chOff x="0" y="0"/>
+          <a:chExt cx="0" cy="0"/>
+        </a:xfrm>
+      </p:grpSpPr>
+      <p:sp>
+        <p:nvSpPr>
+          <p:cNvPr id="3" name="CuadroTexto 2">
+            <a:extLst>
+              <a:ext uri="{FF2B5EF4-FFF2-40B4-BE49-F238E27FC236}">
+                <a16:creationId xmlns:a16="http://schemas.microsoft.com/office/drawing/2014/main" id="{2907C501-E297-57A4-B465-4FE9C7D60002}"/>
+              </a:ext>
+            </a:extLst>
+          </p:cNvPr>
+          <p:cNvSpPr txBox="1"/>
+          <p:nvPr/>
+        </p:nvSpPr>
+        <p:spPr>
+          <a:xfrm>
+            <a:off x="956009" y="1698754"/>
+            <a:ext cx="7117785" cy="4832092"/>
+          </a:xfrm>
+          <a:prstGeom prst="rect">
+            <a:avLst/>
+          </a:prstGeom>
+          <a:noFill/>
+        </p:spPr>
+        <p:txBody>
+          <a:bodyPr wrap="square">
+            <a:spAutoFit/>
+          </a:bodyPr>
+          <a:lstStyle/>
+          <a:p>
+            <a:r>
+              <a:rPr lang="es-419" sz="2800" dirty="0">
+                <a:solidFill>
+                  <a:srgbClr val="272525"/>
+                </a:solidFill>
+                <a:latin typeface="Source Serif 4 Semi Bold" pitchFamily="34" charset="0"/>
+                <a:ea typeface="Source Serif 4 Semi Bold" pitchFamily="34" charset="-122"/>
+              </a:rPr>
+              <a:t>“En Chile ya existen soluciones con IA para orientación </a:t>
+            </a:r>
+            <a:r>
+              <a:rPr lang="es-419" sz="2400" dirty="0">
+                <a:solidFill>
+                  <a:srgbClr val="272525"/>
+                </a:solidFill>
+                <a:latin typeface="Source Serif 4 Semi Bold" pitchFamily="34" charset="0"/>
+                <a:ea typeface="Source Serif 4 Semi Bold" pitchFamily="34" charset="-122"/>
+              </a:rPr>
+              <a:t>médica</a:t>
+            </a:r>
+            <a:r>
+              <a:rPr lang="es-419" sz="2800" dirty="0">
+                <a:solidFill>
+                  <a:srgbClr val="272525"/>
+                </a:solidFill>
+                <a:latin typeface="Source Serif 4 Semi Bold" pitchFamily="34" charset="0"/>
+                <a:ea typeface="Source Serif 4 Semi Bold" pitchFamily="34" charset="-122"/>
+              </a:rPr>
+              <a:t> y </a:t>
+            </a:r>
+            <a:r>
+              <a:rPr lang="es-419" sz="2800" dirty="0" err="1">
+                <a:solidFill>
+                  <a:srgbClr val="272525"/>
+                </a:solidFill>
+                <a:latin typeface="Source Serif 4 Semi Bold" pitchFamily="34" charset="0"/>
+                <a:ea typeface="Source Serif 4 Semi Bold" pitchFamily="34" charset="-122"/>
+              </a:rPr>
+              <a:t>triage</a:t>
+            </a:r>
+            <a:r>
+              <a:rPr lang="es-419" sz="2800" dirty="0">
+                <a:solidFill>
+                  <a:srgbClr val="272525"/>
+                </a:solidFill>
+                <a:latin typeface="Source Serif 4 Semi Bold" pitchFamily="34" charset="0"/>
+                <a:ea typeface="Source Serif 4 Semi Bold" pitchFamily="34" charset="-122"/>
+              </a:rPr>
+              <a:t> (como </a:t>
+            </a:r>
+            <a:r>
+              <a:rPr lang="es-419" sz="2800" dirty="0" err="1">
+                <a:solidFill>
+                  <a:srgbClr val="272525"/>
+                </a:solidFill>
+                <a:latin typeface="Source Serif 4 Semi Bold" pitchFamily="34" charset="0"/>
+                <a:ea typeface="Source Serif 4 Semi Bold" pitchFamily="34" charset="-122"/>
+              </a:rPr>
+              <a:t>Mediko</a:t>
+            </a:r>
+            <a:r>
+              <a:rPr lang="es-419" sz="2800" dirty="0">
+                <a:solidFill>
+                  <a:srgbClr val="272525"/>
+                </a:solidFill>
+                <a:latin typeface="Source Serif 4 Semi Bold" pitchFamily="34" charset="0"/>
+                <a:ea typeface="Source Serif 4 Semi Bold" pitchFamily="34" charset="-122"/>
+              </a:rPr>
+              <a:t> y </a:t>
+            </a:r>
+            <a:r>
+              <a:rPr lang="es-419" sz="2800" dirty="0" err="1">
+                <a:solidFill>
+                  <a:srgbClr val="272525"/>
+                </a:solidFill>
+                <a:latin typeface="Source Serif 4 Semi Bold" pitchFamily="34" charset="0"/>
+                <a:ea typeface="Source Serif 4 Semi Bold" pitchFamily="34" charset="-122"/>
+              </a:rPr>
+              <a:t>SmartTriage</a:t>
+            </a:r>
+            <a:r>
+              <a:rPr lang="es-419" sz="2800" dirty="0">
+                <a:solidFill>
+                  <a:srgbClr val="272525"/>
+                </a:solidFill>
+                <a:latin typeface="Source Serif 4 Semi Bold" pitchFamily="34" charset="0"/>
+                <a:ea typeface="Source Serif 4 Semi Bold" pitchFamily="34" charset="-122"/>
+              </a:rPr>
+              <a:t> en el Hospital de Quintero), pero están enfocadas en orientación general o urgencias. </a:t>
+            </a:r>
+            <a:r>
+              <a:rPr lang="es-419" sz="2800" dirty="0" err="1">
+                <a:solidFill>
+                  <a:srgbClr val="272525"/>
+                </a:solidFill>
+                <a:latin typeface="Source Serif 4 Semi Bold" pitchFamily="34" charset="0"/>
+                <a:ea typeface="Source Serif 4 Semi Bold" pitchFamily="34" charset="-122"/>
+              </a:rPr>
+              <a:t>MediTriage</a:t>
+            </a:r>
+            <a:r>
+              <a:rPr lang="es-419" sz="2800" dirty="0">
+                <a:solidFill>
+                  <a:srgbClr val="272525"/>
+                </a:solidFill>
+                <a:latin typeface="Source Serif 4 Semi Bold" pitchFamily="34" charset="0"/>
+                <a:ea typeface="Source Serif 4 Semi Bold" pitchFamily="34" charset="-122"/>
+              </a:rPr>
+              <a:t> lleva ese enfoque de </a:t>
+            </a:r>
+            <a:r>
+              <a:rPr lang="es-419" sz="2800" dirty="0" err="1">
+                <a:solidFill>
+                  <a:srgbClr val="272525"/>
+                </a:solidFill>
+                <a:latin typeface="Source Serif 4 Semi Bold" pitchFamily="34" charset="0"/>
+                <a:ea typeface="Source Serif 4 Semi Bold" pitchFamily="34" charset="-122"/>
+              </a:rPr>
+              <a:t>triage</a:t>
+            </a:r>
+            <a:r>
+              <a:rPr lang="es-419" sz="2800" dirty="0">
+                <a:solidFill>
+                  <a:srgbClr val="272525"/>
+                </a:solidFill>
+                <a:latin typeface="Source Serif 4 Semi Bold" pitchFamily="34" charset="0"/>
+                <a:ea typeface="Source Serif 4 Semi Bold" pitchFamily="34" charset="-122"/>
+              </a:rPr>
+              <a:t> estructurado directamente al flujo de agendamiento ambulatorio, que es donde hoy se pierden horas, se derivan mal los casos y se saturan las listas de espera.”</a:t>
+            </a:r>
+          </a:p>
+        </p:txBody>
+      </p:sp>
+      <p:pic>
+        <p:nvPicPr>
+          <p:cNvPr id="7" name="Imagen 6" descr="Icono&#10;&#10;El contenido generado por IA puede ser incorrecto.">
+            <a:extLst>
+              <a:ext uri="{FF2B5EF4-FFF2-40B4-BE49-F238E27FC236}">
+                <a16:creationId xmlns:a16="http://schemas.microsoft.com/office/drawing/2014/main" id="{BFD62974-382E-AE19-3C4B-110D62FF2F8C}"/>
+              </a:ext>
+            </a:extLst>
+          </p:cNvPr>
+          <p:cNvPicPr>
+            <a:picLocks noChangeAspect="1"/>
+          </p:cNvPicPr>
+          <p:nvPr/>
+        </p:nvPicPr>
+        <p:blipFill>
+          <a:blip r:embed="rId2"/>
+          <a:stretch>
+            <a:fillRect/>
+          </a:stretch>
+        </p:blipFill>
+        <p:spPr>
+          <a:xfrm>
+            <a:off x="9581322" y="3159714"/>
+            <a:ext cx="4391433" cy="1456285"/>
+          </a:xfrm>
+          <a:prstGeom prst="rect">
+            <a:avLst/>
+          </a:prstGeom>
+        </p:spPr>
+      </p:pic>
+      <p:pic>
+        <p:nvPicPr>
+          <p:cNvPr id="9" name="Imagen 8" descr="Texto, Logotipo&#10;&#10;El contenido generado por IA puede ser incorrecto.">
+            <a:extLst>
+              <a:ext uri="{FF2B5EF4-FFF2-40B4-BE49-F238E27FC236}">
+                <a16:creationId xmlns:a16="http://schemas.microsoft.com/office/drawing/2014/main" id="{45F3C6AB-180E-86D9-0036-92D7CB56CDA0}"/>
+              </a:ext>
+            </a:extLst>
+          </p:cNvPr>
+          <p:cNvPicPr>
+            <a:picLocks noChangeAspect="1"/>
+          </p:cNvPicPr>
+          <p:nvPr/>
+        </p:nvPicPr>
+        <p:blipFill>
+          <a:blip r:embed="rId3"/>
+          <a:stretch>
+            <a:fillRect/>
+          </a:stretch>
+        </p:blipFill>
+        <p:spPr>
+          <a:xfrm>
+            <a:off x="8073794" y="409537"/>
+            <a:ext cx="6810789" cy="2964567"/>
+          </a:xfrm>
+          <a:prstGeom prst="rect">
+            <a:avLst/>
+          </a:prstGeom>
+        </p:spPr>
+      </p:pic>
+      <p:pic>
+        <p:nvPicPr>
+          <p:cNvPr id="11" name="Imagen 10" descr="Texto, Logotipo&#10;&#10;El contenido generado por IA puede ser incorrecto.">
+            <a:extLst>
+              <a:ext uri="{FF2B5EF4-FFF2-40B4-BE49-F238E27FC236}">
+                <a16:creationId xmlns:a16="http://schemas.microsoft.com/office/drawing/2014/main" id="{79E34BD4-4EB5-F43B-5326-3CC1976B00B8}"/>
+              </a:ext>
+            </a:extLst>
+          </p:cNvPr>
+          <p:cNvPicPr>
+            <a:picLocks noChangeAspect="1"/>
+          </p:cNvPicPr>
+          <p:nvPr/>
+        </p:nvPicPr>
+        <p:blipFill>
+          <a:blip r:embed="rId4"/>
+          <a:stretch>
+            <a:fillRect/>
+          </a:stretch>
+        </p:blipFill>
+        <p:spPr>
+          <a:xfrm>
+            <a:off x="7513983" y="3887857"/>
+            <a:ext cx="6810789" cy="4540526"/>
+          </a:xfrm>
+          <a:prstGeom prst="rect">
+            <a:avLst/>
+          </a:prstGeom>
+        </p:spPr>
+      </p:pic>
+      <p:sp>
+        <p:nvSpPr>
+          <p:cNvPr id="12" name="Text 0">
+            <a:extLst>
+              <a:ext uri="{FF2B5EF4-FFF2-40B4-BE49-F238E27FC236}">
+                <a16:creationId xmlns:a16="http://schemas.microsoft.com/office/drawing/2014/main" id="{EB644F70-8139-47C1-A598-B36113F07B3A}"/>
+              </a:ext>
+            </a:extLst>
+          </p:cNvPr>
+          <p:cNvSpPr/>
+          <p:nvPr/>
+        </p:nvSpPr>
+        <p:spPr>
+          <a:xfrm>
+            <a:off x="3504178" y="414414"/>
+            <a:ext cx="5063353" cy="505716"/>
+          </a:xfrm>
+          <a:prstGeom prst="rect">
+            <a:avLst/>
+          </a:prstGeom>
+          <a:noFill/>
+          <a:ln/>
+        </p:spPr>
+        <p:txBody>
+          <a:bodyPr wrap="none" lIns="0" tIns="0" rIns="0" bIns="0" rtlCol="0" anchor="t"/>
+          <a:lstStyle/>
+          <a:p>
+            <a:pPr marL="0" indent="0" algn="l">
+              <a:lnSpc>
+                <a:spcPts val="4400"/>
+              </a:lnSpc>
+              <a:buNone/>
+            </a:pPr>
+            <a:r>
+              <a:rPr lang="es-419" sz="4000" dirty="0">
+                <a:solidFill>
+                  <a:srgbClr val="D73AD7"/>
+                </a:solidFill>
+                <a:latin typeface="Source Serif 4 Semi Bold" pitchFamily="34" charset="0"/>
+                <a:ea typeface="Source Serif 4 Semi Bold" pitchFamily="34" charset="-122"/>
+                <a:cs typeface="Source Serif 4 Semi Bold" pitchFamily="34" charset="-120"/>
+              </a:rPr>
+              <a:t>Propuesta de valor</a:t>
+            </a:r>
+            <a:endParaRPr lang="es-419" sz="4000" noProof="0" dirty="0">
+              <a:solidFill>
+                <a:srgbClr val="D73AD7"/>
+              </a:solidFill>
+              <a:latin typeface="Source Serif 4 Semi Bold" pitchFamily="34" charset="0"/>
+              <a:ea typeface="Source Serif 4 Semi Bold" pitchFamily="34" charset="-122"/>
+              <a:cs typeface="Source Serif 4 Semi Bold" pitchFamily="34" charset="-120"/>
+            </a:endParaRPr>
+          </a:p>
+        </p:txBody>
+      </p:sp>
+    </p:spTree>
+    <p:extLst>
+      <p:ext uri="{BB962C8B-B14F-4D97-AF65-F5344CB8AC3E}">
+        <p14:creationId xmlns:p14="http://schemas.microsoft.com/office/powerpoint/2010/main" val="2412710114"/>
+      </p:ext>
+    </p:extLst>
+  </p:cSld>
+  <p:clrMapOvr>
+    <a:masterClrMapping/>
+  </p:clrMapOvr>
+</p:sld>
+</file>
+
+<file path=ppt/slides/slide13.xml><?xml version="1.0" encoding="utf-8"?>
+<p:sld xmlns:a="http://schemas.openxmlformats.org/drawingml/2006/main" xmlns:r="http://schemas.openxmlformats.org/officeDocument/2006/relationships" xmlns:p="http://schemas.openxmlformats.org/presentationml/2006/main">
+  <p:cSld>
+    <p:spTree>
+      <p:nvGrpSpPr>
         <p:cNvPr id="1" name="">
           <a:extLst>
             <a:ext uri="{FF2B5EF4-FFF2-40B4-BE49-F238E27FC236}">
@@ -6924,7 +7261,7 @@
 </p:sld>
 </file>
 
-<file path=ppt/slides/slide13.xml><?xml version="1.0" encoding="utf-8"?>
+<file path=ppt/slides/slide14.xml><?xml version="1.0" encoding="utf-8"?>
 <p:sld xmlns:a="http://schemas.openxmlformats.org/drawingml/2006/main" xmlns:r="http://schemas.openxmlformats.org/officeDocument/2006/relationships" xmlns:p="http://schemas.openxmlformats.org/presentationml/2006/main">
   <p:cSld>
     <p:spTree>
@@ -7157,7 +7494,7 @@
 </p:sld>
 </file>
 
-<file path=ppt/slides/slide14.xml><?xml version="1.0" encoding="utf-8"?>
+<file path=ppt/slides/slide15.xml><?xml version="1.0" encoding="utf-8"?>
 <p:sld xmlns:a="http://schemas.openxmlformats.org/drawingml/2006/main" xmlns:r="http://schemas.openxmlformats.org/officeDocument/2006/relationships" xmlns:p="http://schemas.openxmlformats.org/presentationml/2006/main">
   <p:cSld>
     <p:spTree>
@@ -7396,7 +7733,7 @@
 </p:sld>
 </file>
 
-<file path=ppt/slides/slide15.xml><?xml version="1.0" encoding="utf-8"?>
+<file path=ppt/slides/slide16.xml><?xml version="1.0" encoding="utf-8"?>
 <p:sld xmlns:a="http://schemas.openxmlformats.org/drawingml/2006/main" xmlns:r="http://schemas.openxmlformats.org/officeDocument/2006/relationships" xmlns:p="http://schemas.openxmlformats.org/presentationml/2006/main">
   <p:cSld>
     <p:spTree>
@@ -11664,4 +12001,24 @@
     </a:ext>
   </a:extLst>
 </a:theme>
+</file>
+
+<file path=ppt/webextensions/taskpanes.xml><?xml version="1.0" encoding="utf-8"?>
+<wetp:taskpanes xmlns:wetp="http://schemas.microsoft.com/office/webextensions/taskpanes/2010/11">
+  <wetp:taskpane dockstate="right" visibility="0" width="350" row="3">
+    <wetp:webextensionref xmlns:r="http://schemas.openxmlformats.org/officeDocument/2006/relationships" r:id="rId1"/>
+  </wetp:taskpane>
+</wetp:taskpanes>
+</file>
+
+<file path=ppt/webextensions/webextension1.xml><?xml version="1.0" encoding="utf-8"?>
+<we:webextension xmlns:we="http://schemas.microsoft.com/office/webextensions/webextension/2010/11" id="{22D00D22-3FE2-4DC4-91DA-B1573F94762D}">
+  <we:reference id="WA200005566" version="3.0.0.3" store="Omex" storeType="OMEX"/>
+  <we:alternateReferences>
+    <we:reference id="WA200005566" version="3.0.0.3" store="WA200005566" storeType="OMEX"/>
+  </we:alternateReferences>
+  <we:properties/>
+  <we:bindings/>
+  <we:snapshot xmlns:r="http://schemas.openxmlformats.org/officeDocument/2006/relationships"/>
+</we:webextension>
 </file>
</xml_diff>